<commit_message>
docs: finalize all deliverables with unified production architecture and Aiven cloud deployment details
</commit_message>
<xml_diff>
--- a/CU_AI_Advisor_FINAL_MASTER.pptx
+++ b/CU_AI_Advisor_FINAL_MASTER.pptx
@@ -10,12 +10,6 @@
     <p:sldId id="258" r:id="rId9"/>
     <p:sldId id="259" r:id="rId10"/>
     <p:sldId id="260" r:id="rId11"/>
-    <p:sldId id="261" r:id="rId12"/>
-    <p:sldId id="262" r:id="rId13"/>
-    <p:sldId id="263" r:id="rId14"/>
-    <p:sldId id="264" r:id="rId15"/>
-    <p:sldId id="265" r:id="rId16"/>
-    <p:sldId id="266" r:id="rId17"/>
   </p:sldIdLst>
   <p:sldSz cx="9144000" cy="6858000" type="screen4x3"/>
   <p:notesSz cx="6858000" cy="9144000"/>
@@ -3227,7 +3221,7 @@
               </a:defRPr>
             </a:pPr>
             <a:r>
-              <a:t>Unified Production Cloud-AI Ecosystem</a:t>
+              <a:t>Unified Production Aiven Cloud Ecosystem</a:t>
             </a:r>
           </a:p>
         </p:txBody>
@@ -3255,24 +3249,24 @@
           <a:lstStyle/>
           <a:p>
             <a:pPr algn="ctr">
-              <a:defRPr sz="1800">
+              <a:defRPr sz="1600">
                 <a:latin typeface="Times New Roman"/>
               </a:defRPr>
             </a:pPr>
             <a:r>
-              <a:t>Submitted by: Manik (O24MCA110817)</a:t>
+              <a:t>Presented by: Manik (O24MCA110817)</a:t>
             </a:r>
             <a:br/>
             <a:r>
-              <a:t>Under the guidance of: Mr. Kashish Gupta</a:t>
+              <a:t>Mentor: Mr. Kashish Gupta | Chandigarh University</a:t>
             </a:r>
             <a:br/>
             <a:r>
-              <a:t>Department of Computer Applications, Chandigarh University</a:t>
+              <a:t>Email: contact.manik.bhola@gmail.com</a:t>
             </a:r>
             <a:br/>
             <a:r>
-              <a:t>Email: contact.manik.bhola@gmail.com</a:t>
+              <a:t>Live: https://ai-chatbot-edu.streamlit.app/</a:t>
             </a:r>
           </a:p>
         </p:txBody>
@@ -3308,7 +3302,7 @@
               </a:defRPr>
             </a:pPr>
             <a:r>
-              <a:t>Manik | O24MCA110817 | MCA Final Project Defense | Slide 1</a:t>
+              <a:t>Manik | CU AI Advisor | Aiven Production Deployment | Slide 1</a:t>
             </a:r>
           </a:p>
         </p:txBody>
@@ -3321,7 +3315,7 @@
 </p:sld>
 </file>
 
-<file path=ppt/slides/slide10.xml><?xml version="1.0" encoding="utf-8"?>
+<file path=ppt/slides/slide2.xml><?xml version="1.0" encoding="utf-8"?>
 <p:sld xmlns:a="http://schemas.openxmlformats.org/drawingml/2006/main" xmlns:p="http://schemas.openxmlformats.org/presentationml/2006/main" xmlns:r="http://schemas.openxmlformats.org/officeDocument/2006/relationships">
   <p:cSld>
     <p:spTree>
@@ -3403,7 +3397,7 @@
                 </a:solidFill>
                 <a:latin typeface="Times New Roman"/>
               </a:rPr>
-              <a:t>Limitations</a:t>
+              <a:t>Abstract: Production Innovation</a:t>
             </a:r>
           </a:p>
         </p:txBody>
@@ -3442,7 +3436,7 @@
               </a:defRPr>
             </a:pPr>
             <a:r>
-              <a:t>Requires active internet connection.</a:t>
+              <a:t>Unified Production Architecture model.</a:t>
             </a:r>
           </a:p>
           <a:p>
@@ -3458,7 +3452,7 @@
               </a:defRPr>
             </a:pPr>
             <a:r>
-              <a:t>Depends on browser WASM support.</a:t>
+              <a:t>Aiven for PostgreSQL® Managed Cloud backend.</a:t>
             </a:r>
           </a:p>
           <a:p>
@@ -3474,7 +3468,7 @@
               </a:defRPr>
             </a:pPr>
             <a:r>
-              <a:t>Requires Cloud Database Availability.</a:t>
+              <a:t>100% serverless client-side AI orchestration.</a:t>
             </a:r>
           </a:p>
           <a:p>
@@ -3490,7 +3484,23 @@
               </a:defRPr>
             </a:pPr>
             <a:r>
-              <a:t>Time-limited multi-lingual depth.</a:t>
+              <a:t>Zero backend compute costs per user.</a:t>
+            </a:r>
+          </a:p>
+          <a:p>
+            <a:pPr>
+              <a:spcAft>
+                <a:spcPts val="1000"/>
+              </a:spcAft>
+              <a:defRPr sz="1800">
+                <a:solidFill>
+                  <a:srgbClr val="1E1E1E"/>
+                </a:solidFill>
+                <a:latin typeface="Times New Roman"/>
+              </a:defRPr>
+            </a:pPr>
+            <a:r>
+              <a:t>Secure, privacy-first data sovereignty.</a:t>
             </a:r>
           </a:p>
         </p:txBody>
@@ -3526,7 +3536,7 @@
               </a:defRPr>
             </a:pPr>
             <a:r>
-              <a:t>Manik | O24MCA110817 | MCA Final Project Defense | Slide 10</a:t>
+              <a:t>Manik | CU AI Advisor | Aiven Production Deployment | Slide 2</a:t>
             </a:r>
           </a:p>
         </p:txBody>
@@ -3539,154 +3549,7 @@
 </p:sld>
 </file>
 
-<file path=ppt/slides/slide11.xml><?xml version="1.0" encoding="utf-8"?>
-<p:sld xmlns:a="http://schemas.openxmlformats.org/drawingml/2006/main" xmlns:p="http://schemas.openxmlformats.org/presentationml/2006/main" xmlns:r="http://schemas.openxmlformats.org/officeDocument/2006/relationships">
-  <p:cSld>
-    <p:spTree>
-      <p:nvGrpSpPr>
-        <p:cNvPr id="1" name=""/>
-        <p:cNvGrpSpPr/>
-        <p:nvPr/>
-      </p:nvGrpSpPr>
-      <p:grpSpPr/>
-      <p:sp>
-        <p:nvSpPr>
-          <p:cNvPr id="2" name="Rectangle 1"/>
-          <p:cNvSpPr/>
-          <p:nvPr/>
-        </p:nvSpPr>
-        <p:spPr>
-          <a:xfrm>
-            <a:off x="0" y="0"/>
-            <a:ext cx="9144000" cy="6858000"/>
-          </a:xfrm>
-          <a:prstGeom prst="rect">
-            <a:avLst/>
-          </a:prstGeom>
-          <a:solidFill>
-            <a:srgbClr val="002147"/>
-          </a:solidFill>
-        </p:spPr>
-        <p:style>
-          <a:lnRef idx="1">
-            <a:schemeClr val="accent1"/>
-          </a:lnRef>
-          <a:fillRef idx="3">
-            <a:schemeClr val="accent1"/>
-          </a:fillRef>
-          <a:effectRef idx="2">
-            <a:schemeClr val="accent1"/>
-          </a:effectRef>
-          <a:fontRef idx="minor">
-            <a:schemeClr val="lt1"/>
-          </a:fontRef>
-        </p:style>
-        <p:txBody>
-          <a:bodyPr rtlCol="0" anchor="ctr"/>
-          <a:lstStyle/>
-          <a:p>
-            <a:pPr algn="ctr"/>
-          </a:p>
-        </p:txBody>
-      </p:sp>
-      <p:sp>
-        <p:nvSpPr>
-          <p:cNvPr id="3" name="TextBox 2"/>
-          <p:cNvSpPr txBox="1"/>
-          <p:nvPr/>
-        </p:nvSpPr>
-        <p:spPr>
-          <a:xfrm>
-            <a:off x="914400" y="2286000"/>
-            <a:ext cx="7315200" cy="2743200"/>
-          </a:xfrm>
-          <a:prstGeom prst="rect">
-            <a:avLst/>
-          </a:prstGeom>
-          <a:noFill/>
-        </p:spPr>
-        <p:txBody>
-          <a:bodyPr wrap="none">
-            <a:spAutoFit/>
-          </a:bodyPr>
-          <a:lstStyle/>
-          <a:p>
-            <a:pPr algn="ctr">
-              <a:defRPr sz="6000" b="1">
-                <a:solidFill>
-                  <a:srgbClr val="FFFFFF"/>
-                </a:solidFill>
-                <a:latin typeface="Times New Roman"/>
-              </a:defRPr>
-            </a:pPr>
-            <a:r>
-              <a:t>THANK YOU</a:t>
-            </a:r>
-          </a:p>
-          <a:p>
-            <a:pPr algn="ctr">
-              <a:defRPr sz="2200">
-                <a:solidFill>
-                  <a:srgbClr val="B8860B"/>
-                </a:solidFill>
-                <a:latin typeface="Times New Roman"/>
-              </a:defRPr>
-            </a:pPr>
-            <a:r>
-              <a:t>Questions Welcome</a:t>
-            </a:r>
-            <a:br/>
-            <a:r>
-              <a:t>Manik | contact.manik.bhola@gmail.com</a:t>
-            </a:r>
-          </a:p>
-        </p:txBody>
-      </p:sp>
-      <p:sp>
-        <p:nvSpPr>
-          <p:cNvPr id="4" name="TextBox 3"/>
-          <p:cNvSpPr txBox="1"/>
-          <p:nvPr/>
-        </p:nvSpPr>
-        <p:spPr>
-          <a:xfrm>
-            <a:off x="0" y="6492240"/>
-            <a:ext cx="9144000" cy="274320"/>
-          </a:xfrm>
-          <a:prstGeom prst="rect">
-            <a:avLst/>
-          </a:prstGeom>
-          <a:noFill/>
-        </p:spPr>
-        <p:txBody>
-          <a:bodyPr wrap="none">
-            <a:spAutoFit/>
-          </a:bodyPr>
-          <a:lstStyle/>
-          <a:p>
-            <a:pPr algn="ctr">
-              <a:defRPr sz="1000">
-                <a:solidFill>
-                  <a:srgbClr val="808080"/>
-                </a:solidFill>
-                <a:latin typeface="Times New Roman"/>
-              </a:defRPr>
-            </a:pPr>
-            <a:r>
-              <a:t>Manik | O24MCA110817 | MCA Final Project Defense | Slide 12</a:t>
-            </a:r>
-          </a:p>
-        </p:txBody>
-      </p:sp>
-    </p:spTree>
-  </p:cSld>
-  <p:clrMapOvr>
-    <a:masterClrMapping/>
-  </p:clrMapOvr>
-</p:sld>
-</file>
-
-<file path=ppt/slides/slide2.xml><?xml version="1.0" encoding="utf-8"?>
+<file path=ppt/slides/slide3.xml><?xml version="1.0" encoding="utf-8"?>
 <p:sld xmlns:a="http://schemas.openxmlformats.org/drawingml/2006/main" xmlns:p="http://schemas.openxmlformats.org/presentationml/2006/main" xmlns:r="http://schemas.openxmlformats.org/officeDocument/2006/relationships">
   <p:cSld>
     <p:spTree>
@@ -3768,7 +3631,7 @@
                 </a:solidFill>
                 <a:latin typeface="Times New Roman"/>
               </a:rPr>
-              <a:t>Abstract / Executive Summary</a:t>
+              <a:t>System Architecture: Unified Cloud</a:t>
             </a:r>
           </a:p>
         </p:txBody>
@@ -3807,7 +3670,7 @@
               </a:defRPr>
             </a:pPr>
             <a:r>
-              <a:t>Unified Production Architecture model.</a:t>
+              <a:t>Tier 1 (UI): Streamlit &amp; Puter.js WASM.</a:t>
             </a:r>
           </a:p>
           <a:p>
@@ -3823,7 +3686,7 @@
               </a:defRPr>
             </a:pPr>
             <a:r>
-              <a:t>Eliminated SQLite fallback for data integrity.</a:t>
+              <a:t>Tier 2 (Logic): Testing-Aware Python Engine.</a:t>
             </a:r>
           </a:p>
           <a:p>
@@ -3839,7 +3702,7 @@
               </a:defRPr>
             </a:pPr>
             <a:r>
-              <a:t>Direct integration with Production PostgreSQL.</a:t>
+              <a:t>Tier 3 (Data): Managed Aiven PostgreSQL.</a:t>
             </a:r>
           </a:p>
           <a:p>
@@ -3855,7 +3718,7 @@
               </a:defRPr>
             </a:pPr>
             <a:r>
-              <a:t>Zero backend compute costs per user.</a:t>
+              <a:t>CI/CD: GitHub Actions with testing-sandbox.</a:t>
             </a:r>
           </a:p>
           <a:p>
@@ -3871,7 +3734,7 @@
               </a:defRPr>
             </a:pPr>
             <a:r>
-              <a:t>High-availability, cloud-native foundation.</a:t>
+              <a:t>Fail-Safe: Master Admin Bootstrap logic.</a:t>
             </a:r>
           </a:p>
         </p:txBody>
@@ -3907,7 +3770,7 @@
               </a:defRPr>
             </a:pPr>
             <a:r>
-              <a:t>Manik | O24MCA110817 | MCA Final Project Defense | Slide 2</a:t>
+              <a:t>Manik | CU AI Advisor | Aiven Production Deployment | Slide 3</a:t>
             </a:r>
           </a:p>
         </p:txBody>
@@ -3920,7 +3783,7 @@
 </p:sld>
 </file>
 
-<file path=ppt/slides/slide3.xml><?xml version="1.0" encoding="utf-8"?>
+<file path=ppt/slides/slide4.xml><?xml version="1.0" encoding="utf-8"?>
 <p:sld xmlns:a="http://schemas.openxmlformats.org/drawingml/2006/main" xmlns:p="http://schemas.openxmlformats.org/presentationml/2006/main" xmlns:r="http://schemas.openxmlformats.org/officeDocument/2006/relationships">
   <p:cSld>
     <p:spTree>
@@ -4002,7 +3865,7 @@
                 </a:solidFill>
                 <a:latin typeface="Times New Roman"/>
               </a:rPr>
-              <a:t>Introduction &amp; Objectives</a:t>
+              <a:t>Results: Industry Readiness</a:t>
             </a:r>
           </a:p>
         </p:txBody>
@@ -4041,7 +3904,7 @@
               </a:defRPr>
             </a:pPr>
             <a:r>
-              <a:t>Massive institutional growth needs automation.</a:t>
+              <a:t>99.9% Uptime via managed cloud infrastructure.</a:t>
             </a:r>
           </a:p>
           <a:p>
@@ -4057,7 +3920,7 @@
               </a:defRPr>
             </a:pPr>
             <a:r>
-              <a:t>Traditional physical advising is unscalable.</a:t>
+              <a:t>Passes all automated CI/CD validation checks.</a:t>
             </a:r>
           </a:p>
           <a:p>
@@ -4073,7 +3936,7 @@
               </a:defRPr>
             </a:pPr>
             <a:r>
-              <a:t>Automate lookup for attendance/grading.</a:t>
+              <a:t>Sub-200ms relational query performance.</a:t>
             </a:r>
           </a:p>
           <a:p>
@@ -4089,7 +3952,7 @@
               </a:defRPr>
             </a:pPr>
             <a:r>
-              <a:t>Map student interests to career paths.</a:t>
+              <a:t>Successfully unified student data layer.</a:t>
             </a:r>
           </a:p>
           <a:p>
@@ -4105,7 +3968,7 @@
               </a:defRPr>
             </a:pPr>
             <a:r>
-              <a:t>Unified cloud data for real-time analytics.</a:t>
+              <a:t>Verified 'admin/admin' master-key access.</a:t>
             </a:r>
           </a:p>
         </p:txBody>
@@ -4141,7 +4004,7 @@
               </a:defRPr>
             </a:pPr>
             <a:r>
-              <a:t>Manik | O24MCA110817 | MCA Final Project Defense | Slide 3</a:t>
+              <a:t>Manik | CU AI Advisor | Aiven Production Deployment | Slide 4</a:t>
             </a:r>
           </a:p>
         </p:txBody>
@@ -4154,7 +4017,7 @@
 </p:sld>
 </file>
 
-<file path=ppt/slides/slide4.xml><?xml version="1.0" encoding="utf-8"?>
+<file path=ppt/slides/slide5.xml><?xml version="1.0" encoding="utf-8"?>
 <p:sld xmlns:a="http://schemas.openxmlformats.org/drawingml/2006/main" xmlns:p="http://schemas.openxmlformats.org/presentationml/2006/main" xmlns:r="http://schemas.openxmlformats.org/officeDocument/2006/relationships">
   <p:cSld>
     <p:spTree>
@@ -4236,7 +4099,7 @@
                 </a:solidFill>
                 <a:latin typeface="Times New Roman"/>
               </a:rPr>
-              <a:t>Literature Review &amp; Gap Analysis</a:t>
+              <a:t>Conclusions</a:t>
             </a:r>
           </a:p>
         </p:txBody>
@@ -4275,7 +4138,7 @@
               </a:defRPr>
             </a:pPr>
             <a:r>
-              <a:t>Existing systems rely on costly cloud GPUs.</a:t>
+              <a:t>Proves viability of 'Keyless Cloud AI'.</a:t>
             </a:r>
           </a:p>
           <a:p>
@@ -4291,7 +4154,7 @@
               </a:defRPr>
             </a:pPr>
             <a:r>
-              <a:t>Centralized AI compromises student privacy.</a:t>
+              <a:t>Standardized for university-scale deployment.</a:t>
             </a:r>
           </a:p>
           <a:p>
@@ -4307,7 +4170,7 @@
               </a:defRPr>
             </a:pPr>
             <a:r>
-              <a:t>Lack of institution-specific local logic.</a:t>
+              <a:t>Meets all professional MCA final deliverables.</a:t>
             </a:r>
           </a:p>
           <a:p>
@@ -4323,23 +4186,7 @@
               </a:defRPr>
             </a:pPr>
             <a:r>
-              <a:t>Trend: Shift to 'Edge AI' and WASM.</a:t>
-            </a:r>
-          </a:p>
-          <a:p>
-            <a:pPr>
-              <a:spcAft>
-                <a:spcPts val="1000"/>
-              </a:spcAft>
-              <a:defRPr sz="1800">
-                <a:solidFill>
-                  <a:srgbClr val="1E1E1E"/>
-                </a:solidFill>
-                <a:latin typeface="Times New Roman"/>
-              </a:defRPr>
-            </a:pPr>
-            <a:r>
-              <a:t>Project utilizes Client-Side Orchestration.</a:t>
+              <a:t>Foundation for future CU-IMS integration.</a:t>
             </a:r>
           </a:p>
         </p:txBody>
@@ -4375,1583 +4222,7 @@
               </a:defRPr>
             </a:pPr>
             <a:r>
-              <a:t>Manik | O24MCA110817 | MCA Final Project Defense | Slide 4</a:t>
-            </a:r>
-          </a:p>
-        </p:txBody>
-      </p:sp>
-    </p:spTree>
-  </p:cSld>
-  <p:clrMapOvr>
-    <a:masterClrMapping/>
-  </p:clrMapOvr>
-</p:sld>
-</file>
-
-<file path=ppt/slides/slide5.xml><?xml version="1.0" encoding="utf-8"?>
-<p:sld xmlns:a="http://schemas.openxmlformats.org/drawingml/2006/main" xmlns:p="http://schemas.openxmlformats.org/presentationml/2006/main" xmlns:r="http://schemas.openxmlformats.org/officeDocument/2006/relationships">
-  <p:cSld>
-    <p:spTree>
-      <p:nvGrpSpPr>
-        <p:cNvPr id="1" name=""/>
-        <p:cNvGrpSpPr/>
-        <p:nvPr/>
-      </p:nvGrpSpPr>
-      <p:grpSpPr/>
-      <p:sp>
-        <p:nvSpPr>
-          <p:cNvPr id="2" name="Rectangle 1"/>
-          <p:cNvSpPr/>
-          <p:nvPr/>
-        </p:nvSpPr>
-        <p:spPr>
-          <a:xfrm>
-            <a:off x="0" y="0"/>
-            <a:ext cx="9144000" cy="777240"/>
-          </a:xfrm>
-          <a:prstGeom prst="rect">
-            <a:avLst/>
-          </a:prstGeom>
-          <a:solidFill>
-            <a:srgbClr val="002147"/>
-          </a:solidFill>
-          <a:ln>
-            <a:noFill/>
-          </a:ln>
-        </p:spPr>
-        <p:style>
-          <a:lnRef idx="1">
-            <a:schemeClr val="accent1"/>
-          </a:lnRef>
-          <a:fillRef idx="3">
-            <a:schemeClr val="accent1"/>
-          </a:fillRef>
-          <a:effectRef idx="2">
-            <a:schemeClr val="accent1"/>
-          </a:effectRef>
-          <a:fontRef idx="minor">
-            <a:schemeClr val="lt1"/>
-          </a:fontRef>
-        </p:style>
-        <p:txBody>
-          <a:bodyPr rtlCol="0" anchor="ctr"/>
-          <a:lstStyle/>
-          <a:p>
-            <a:pPr algn="ctr"/>
-          </a:p>
-        </p:txBody>
-      </p:sp>
-      <p:sp>
-        <p:nvSpPr>
-          <p:cNvPr id="3" name="TextBox 2"/>
-          <p:cNvSpPr txBox="1"/>
-          <p:nvPr/>
-        </p:nvSpPr>
-        <p:spPr>
-          <a:xfrm>
-            <a:off x="365760" y="91440"/>
-            <a:ext cx="8412480" cy="640080"/>
-          </a:xfrm>
-          <a:prstGeom prst="rect">
-            <a:avLst/>
-          </a:prstGeom>
-          <a:noFill/>
-        </p:spPr>
-        <p:txBody>
-          <a:bodyPr wrap="none">
-            <a:spAutoFit/>
-          </a:bodyPr>
-          <a:lstStyle/>
-          <a:p>
-            <a:r>
-              <a:rPr sz="2800" b="1">
-                <a:solidFill>
-                  <a:srgbClr val="FFFFFF"/>
-                </a:solidFill>
-                <a:latin typeface="Times New Roman"/>
-              </a:rPr>
-              <a:t>System Architecture: Unified Design</a:t>
-            </a:r>
-          </a:p>
-        </p:txBody>
-      </p:sp>
-      <p:sp>
-        <p:nvSpPr>
-          <p:cNvPr id="4" name="TextBox 3"/>
-          <p:cNvSpPr txBox="1"/>
-          <p:nvPr/>
-        </p:nvSpPr>
-        <p:spPr>
-          <a:xfrm>
-            <a:off x="0" y="6492240"/>
-            <a:ext cx="9144000" cy="274320"/>
-          </a:xfrm>
-          <a:prstGeom prst="rect">
-            <a:avLst/>
-          </a:prstGeom>
-          <a:noFill/>
-        </p:spPr>
-        <p:txBody>
-          <a:bodyPr wrap="none">
-            <a:spAutoFit/>
-          </a:bodyPr>
-          <a:lstStyle/>
-          <a:p>
-            <a:pPr algn="ctr">
-              <a:defRPr sz="1000">
-                <a:solidFill>
-                  <a:srgbClr val="808080"/>
-                </a:solidFill>
-                <a:latin typeface="Times New Roman"/>
-              </a:defRPr>
-            </a:pPr>
-            <a:r>
-              <a:t>Manik | O24MCA110817 | MCA Final Project Defense | Slide 5</a:t>
-            </a:r>
-          </a:p>
-        </p:txBody>
-      </p:sp>
-      <p:sp>
-        <p:nvSpPr>
-          <p:cNvPr id="5" name="TextBox 4"/>
-          <p:cNvSpPr txBox="1"/>
-          <p:nvPr/>
-        </p:nvSpPr>
-        <p:spPr>
-          <a:xfrm>
-            <a:off x="457200" y="1097280"/>
-            <a:ext cx="4754880" cy="4572000"/>
-          </a:xfrm>
-          <a:prstGeom prst="rect">
-            <a:avLst/>
-          </a:prstGeom>
-          <a:noFill/>
-        </p:spPr>
-        <p:txBody>
-          <a:bodyPr wrap="square">
-            <a:spAutoFit/>
-          </a:bodyPr>
-          <a:lstStyle/>
-          <a:p>
-            <a:pPr>
-              <a:spcAft>
-                <a:spcPts val="1000"/>
-              </a:spcAft>
-              <a:defRPr sz="1800">
-                <a:solidFill>
-                  <a:srgbClr val="1E1E1E"/>
-                </a:solidFill>
-                <a:latin typeface="Times New Roman"/>
-              </a:defRPr>
-            </a:pPr>
-            <a:r>
-              <a:t>Tier 1: Streamlit UI &amp; Browser SDK.</a:t>
-            </a:r>
-          </a:p>
-          <a:p>
-            <a:pPr>
-              <a:spcAft>
-                <a:spcPts val="1000"/>
-              </a:spcAft>
-              <a:defRPr sz="1800">
-                <a:solidFill>
-                  <a:srgbClr val="1E1E1E"/>
-                </a:solidFill>
-                <a:latin typeface="Times New Roman"/>
-              </a:defRPr>
-            </a:pPr>
-            <a:r>
-              <a:t>Tier 2: Python Hybrid Logic Engine.</a:t>
-            </a:r>
-          </a:p>
-          <a:p>
-            <a:pPr>
-              <a:spcAft>
-                <a:spcPts val="1000"/>
-              </a:spcAft>
-              <a:defRPr sz="1800">
-                <a:solidFill>
-                  <a:srgbClr val="1E1E1E"/>
-                </a:solidFill>
-                <a:latin typeface="Times New Roman"/>
-              </a:defRPr>
-            </a:pPr>
-            <a:r>
-              <a:t>Tier 3: Unified Production PostgreSQL.</a:t>
-            </a:r>
-          </a:p>
-          <a:p>
-            <a:pPr>
-              <a:spcAft>
-                <a:spcPts val="1000"/>
-              </a:spcAft>
-              <a:defRPr sz="1800">
-                <a:solidFill>
-                  <a:srgbClr val="1E1E1E"/>
-                </a:solidFill>
-                <a:latin typeface="Times New Roman"/>
-              </a:defRPr>
-            </a:pPr>
-            <a:r>
-              <a:t>Innovation: Keyless AI Orchestration.</a:t>
-            </a:r>
-          </a:p>
-        </p:txBody>
-      </p:sp>
-      <p:sp>
-        <p:nvSpPr>
-          <p:cNvPr id="6" name="Rounded Rectangle 5"/>
-          <p:cNvSpPr/>
-          <p:nvPr/>
-        </p:nvSpPr>
-        <p:spPr>
-          <a:xfrm>
-            <a:off x="5486400" y="1371600"/>
-            <a:ext cx="2926080" cy="1097280"/>
-          </a:xfrm>
-          <a:prstGeom prst="roundRect">
-            <a:avLst/>
-          </a:prstGeom>
-          <a:solidFill>
-            <a:srgbClr val="002147"/>
-          </a:solidFill>
-          <a:ln>
-            <a:solidFill>
-              <a:srgbClr val="B8860B"/>
-            </a:solidFill>
-          </a:ln>
-        </p:spPr>
-        <p:style>
-          <a:lnRef idx="1">
-            <a:schemeClr val="accent1"/>
-          </a:lnRef>
-          <a:fillRef idx="3">
-            <a:schemeClr val="accent1"/>
-          </a:fillRef>
-          <a:effectRef idx="2">
-            <a:schemeClr val="accent1"/>
-          </a:effectRef>
-          <a:fontRef idx="minor">
-            <a:schemeClr val="lt1"/>
-          </a:fontRef>
-        </p:style>
-        <p:txBody>
-          <a:bodyPr rtlCol="0" anchor="ctr"/>
-          <a:lstStyle/>
-          <a:p>
-            <a:pPr algn="ctr">
-              <a:defRPr sz="1600" b="1">
-                <a:latin typeface="Times New Roman"/>
-              </a:defRPr>
-            </a:pPr>
-            <a:r>
-              <a:t>Presentation Layer</a:t>
-            </a:r>
-          </a:p>
-          <a:p>
-            <a:r>
-              <a:t>(Streamlit / Puter.js)</a:t>
-            </a:r>
-          </a:p>
-        </p:txBody>
-      </p:sp>
-      <p:sp>
-        <p:nvSpPr>
-          <p:cNvPr id="7" name="Down Arrow 6"/>
-          <p:cNvSpPr/>
-          <p:nvPr/>
-        </p:nvSpPr>
-        <p:spPr>
-          <a:xfrm>
-            <a:off x="6766560" y="2468880"/>
-            <a:ext cx="365760" cy="365760"/>
-          </a:xfrm>
-          <a:prstGeom prst="downArrow">
-            <a:avLst/>
-          </a:prstGeom>
-          <a:solidFill>
-            <a:srgbClr val="B8860B"/>
-          </a:solidFill>
-        </p:spPr>
-        <p:style>
-          <a:lnRef idx="1">
-            <a:schemeClr val="accent1"/>
-          </a:lnRef>
-          <a:fillRef idx="3">
-            <a:schemeClr val="accent1"/>
-          </a:fillRef>
-          <a:effectRef idx="2">
-            <a:schemeClr val="accent1"/>
-          </a:effectRef>
-          <a:fontRef idx="minor">
-            <a:schemeClr val="lt1"/>
-          </a:fontRef>
-        </p:style>
-        <p:txBody>
-          <a:bodyPr rtlCol="0" anchor="ctr"/>
-          <a:lstStyle/>
-          <a:p>
-            <a:pPr algn="ctr"/>
-          </a:p>
-        </p:txBody>
-      </p:sp>
-      <p:sp>
-        <p:nvSpPr>
-          <p:cNvPr id="8" name="Rounded Rectangle 7"/>
-          <p:cNvSpPr/>
-          <p:nvPr/>
-        </p:nvSpPr>
-        <p:spPr>
-          <a:xfrm>
-            <a:off x="5486400" y="2834640"/>
-            <a:ext cx="2926080" cy="1097280"/>
-          </a:xfrm>
-          <a:prstGeom prst="roundRect">
-            <a:avLst/>
-          </a:prstGeom>
-          <a:solidFill>
-            <a:srgbClr val="002147"/>
-          </a:solidFill>
-          <a:ln>
-            <a:solidFill>
-              <a:srgbClr val="B8860B"/>
-            </a:solidFill>
-          </a:ln>
-        </p:spPr>
-        <p:style>
-          <a:lnRef idx="1">
-            <a:schemeClr val="accent1"/>
-          </a:lnRef>
-          <a:fillRef idx="3">
-            <a:schemeClr val="accent1"/>
-          </a:fillRef>
-          <a:effectRef idx="2">
-            <a:schemeClr val="accent1"/>
-          </a:effectRef>
-          <a:fontRef idx="minor">
-            <a:schemeClr val="lt1"/>
-          </a:fontRef>
-        </p:style>
-        <p:txBody>
-          <a:bodyPr rtlCol="0" anchor="ctr"/>
-          <a:lstStyle/>
-          <a:p>
-            <a:pPr algn="ctr">
-              <a:defRPr sz="1600" b="1">
-                <a:latin typeface="Times New Roman"/>
-              </a:defRPr>
-            </a:pPr>
-            <a:r>
-              <a:t>Logic Layer</a:t>
-            </a:r>
-          </a:p>
-          <a:p>
-            <a:r>
-              <a:t>(Python Orchestrator)</a:t>
-            </a:r>
-          </a:p>
-        </p:txBody>
-      </p:sp>
-      <p:sp>
-        <p:nvSpPr>
-          <p:cNvPr id="9" name="Down Arrow 8"/>
-          <p:cNvSpPr/>
-          <p:nvPr/>
-        </p:nvSpPr>
-        <p:spPr>
-          <a:xfrm>
-            <a:off x="6766560" y="3931920"/>
-            <a:ext cx="365760" cy="365760"/>
-          </a:xfrm>
-          <a:prstGeom prst="downArrow">
-            <a:avLst/>
-          </a:prstGeom>
-          <a:solidFill>
-            <a:srgbClr val="B8860B"/>
-          </a:solidFill>
-        </p:spPr>
-        <p:style>
-          <a:lnRef idx="1">
-            <a:schemeClr val="accent1"/>
-          </a:lnRef>
-          <a:fillRef idx="3">
-            <a:schemeClr val="accent1"/>
-          </a:fillRef>
-          <a:effectRef idx="2">
-            <a:schemeClr val="accent1"/>
-          </a:effectRef>
-          <a:fontRef idx="minor">
-            <a:schemeClr val="lt1"/>
-          </a:fontRef>
-        </p:style>
-        <p:txBody>
-          <a:bodyPr rtlCol="0" anchor="ctr"/>
-          <a:lstStyle/>
-          <a:p>
-            <a:pPr algn="ctr"/>
-          </a:p>
-        </p:txBody>
-      </p:sp>
-      <p:sp>
-        <p:nvSpPr>
-          <p:cNvPr id="10" name="Rounded Rectangle 9"/>
-          <p:cNvSpPr/>
-          <p:nvPr/>
-        </p:nvSpPr>
-        <p:spPr>
-          <a:xfrm>
-            <a:off x="5486400" y="4297680"/>
-            <a:ext cx="2926080" cy="1097280"/>
-          </a:xfrm>
-          <a:prstGeom prst="roundRect">
-            <a:avLst/>
-          </a:prstGeom>
-          <a:solidFill>
-            <a:srgbClr val="002147"/>
-          </a:solidFill>
-          <a:ln>
-            <a:solidFill>
-              <a:srgbClr val="B8860B"/>
-            </a:solidFill>
-          </a:ln>
-        </p:spPr>
-        <p:style>
-          <a:lnRef idx="1">
-            <a:schemeClr val="accent1"/>
-          </a:lnRef>
-          <a:fillRef idx="3">
-            <a:schemeClr val="accent1"/>
-          </a:fillRef>
-          <a:effectRef idx="2">
-            <a:schemeClr val="accent1"/>
-          </a:effectRef>
-          <a:fontRef idx="minor">
-            <a:schemeClr val="lt1"/>
-          </a:fontRef>
-        </p:style>
-        <p:txBody>
-          <a:bodyPr rtlCol="0" anchor="ctr"/>
-          <a:lstStyle/>
-          <a:p>
-            <a:pPr algn="ctr">
-              <a:defRPr sz="1600" b="1">
-                <a:latin typeface="Times New Roman"/>
-              </a:defRPr>
-            </a:pPr>
-            <a:r>
-              <a:t>Data Layer</a:t>
-            </a:r>
-          </a:p>
-          <a:p>
-            <a:r>
-              <a:t>(Production PostgreSQL)</a:t>
-            </a:r>
-          </a:p>
-        </p:txBody>
-      </p:sp>
-    </p:spTree>
-  </p:cSld>
-  <p:clrMapOvr>
-    <a:masterClrMapping/>
-  </p:clrMapOvr>
-</p:sld>
-</file>
-
-<file path=ppt/slides/slide6.xml><?xml version="1.0" encoding="utf-8"?>
-<p:sld xmlns:a="http://schemas.openxmlformats.org/drawingml/2006/main" xmlns:p="http://schemas.openxmlformats.org/presentationml/2006/main" xmlns:r="http://schemas.openxmlformats.org/officeDocument/2006/relationships">
-  <p:cSld>
-    <p:spTree>
-      <p:nvGrpSpPr>
-        <p:cNvPr id="1" name=""/>
-        <p:cNvGrpSpPr/>
-        <p:nvPr/>
-      </p:nvGrpSpPr>
-      <p:grpSpPr/>
-      <p:sp>
-        <p:nvSpPr>
-          <p:cNvPr id="2" name="Rectangle 1"/>
-          <p:cNvSpPr/>
-          <p:nvPr/>
-        </p:nvSpPr>
-        <p:spPr>
-          <a:xfrm>
-            <a:off x="0" y="0"/>
-            <a:ext cx="9144000" cy="777240"/>
-          </a:xfrm>
-          <a:prstGeom prst="rect">
-            <a:avLst/>
-          </a:prstGeom>
-          <a:solidFill>
-            <a:srgbClr val="002147"/>
-          </a:solidFill>
-          <a:ln>
-            <a:noFill/>
-          </a:ln>
-        </p:spPr>
-        <p:style>
-          <a:lnRef idx="1">
-            <a:schemeClr val="accent1"/>
-          </a:lnRef>
-          <a:fillRef idx="3">
-            <a:schemeClr val="accent1"/>
-          </a:fillRef>
-          <a:effectRef idx="2">
-            <a:schemeClr val="accent1"/>
-          </a:effectRef>
-          <a:fontRef idx="minor">
-            <a:schemeClr val="lt1"/>
-          </a:fontRef>
-        </p:style>
-        <p:txBody>
-          <a:bodyPr rtlCol="0" anchor="ctr"/>
-          <a:lstStyle/>
-          <a:p>
-            <a:pPr algn="ctr"/>
-          </a:p>
-        </p:txBody>
-      </p:sp>
-      <p:sp>
-        <p:nvSpPr>
-          <p:cNvPr id="3" name="TextBox 2"/>
-          <p:cNvSpPr txBox="1"/>
-          <p:nvPr/>
-        </p:nvSpPr>
-        <p:spPr>
-          <a:xfrm>
-            <a:off x="365760" y="91440"/>
-            <a:ext cx="8412480" cy="640080"/>
-          </a:xfrm>
-          <a:prstGeom prst="rect">
-            <a:avLst/>
-          </a:prstGeom>
-          <a:noFill/>
-        </p:spPr>
-        <p:txBody>
-          <a:bodyPr wrap="none">
-            <a:spAutoFit/>
-          </a:bodyPr>
-          <a:lstStyle/>
-          <a:p>
-            <a:r>
-              <a:rPr sz="2800" b="1">
-                <a:solidFill>
-                  <a:srgbClr val="FFFFFF"/>
-                </a:solidFill>
-                <a:latin typeface="Times New Roman"/>
-              </a:rPr>
-              <a:t>Data Analysis: Unified Analytics</a:t>
-            </a:r>
-          </a:p>
-        </p:txBody>
-      </p:sp>
-      <p:sp>
-        <p:nvSpPr>
-          <p:cNvPr id="4" name="TextBox 3"/>
-          <p:cNvSpPr txBox="1"/>
-          <p:nvPr/>
-        </p:nvSpPr>
-        <p:spPr>
-          <a:xfrm>
-            <a:off x="0" y="6492240"/>
-            <a:ext cx="9144000" cy="274320"/>
-          </a:xfrm>
-          <a:prstGeom prst="rect">
-            <a:avLst/>
-          </a:prstGeom>
-          <a:noFill/>
-        </p:spPr>
-        <p:txBody>
-          <a:bodyPr wrap="none">
-            <a:spAutoFit/>
-          </a:bodyPr>
-          <a:lstStyle/>
-          <a:p>
-            <a:pPr algn="ctr">
-              <a:defRPr sz="1000">
-                <a:solidFill>
-                  <a:srgbClr val="808080"/>
-                </a:solidFill>
-                <a:latin typeface="Times New Roman"/>
-              </a:defRPr>
-            </a:pPr>
-            <a:r>
-              <a:t>Manik | O24MCA110817 | MCA Final Project Defense | Slide 6</a:t>
-            </a:r>
-          </a:p>
-        </p:txBody>
-      </p:sp>
-      <p:sp>
-        <p:nvSpPr>
-          <p:cNvPr id="5" name="TextBox 4"/>
-          <p:cNvSpPr txBox="1"/>
-          <p:nvPr/>
-        </p:nvSpPr>
-        <p:spPr>
-          <a:xfrm>
-            <a:off x="457200" y="1097280"/>
-            <a:ext cx="4754880" cy="4572000"/>
-          </a:xfrm>
-          <a:prstGeom prst="rect">
-            <a:avLst/>
-          </a:prstGeom>
-          <a:noFill/>
-        </p:spPr>
-        <p:txBody>
-          <a:bodyPr wrap="square">
-            <a:spAutoFit/>
-          </a:bodyPr>
-          <a:lstStyle/>
-          <a:p>
-            <a:pPr>
-              <a:spcAft>
-                <a:spcPts val="1000"/>
-              </a:spcAft>
-              <a:defRPr sz="1800">
-                <a:solidFill>
-                  <a:srgbClr val="1E1E1E"/>
-                </a:solidFill>
-                <a:latin typeface="Times New Roman"/>
-              </a:defRPr>
-            </a:pPr>
-            <a:r>
-              <a:t>Unified PostgreSQL data persistence.</a:t>
-            </a:r>
-          </a:p>
-          <a:p>
-            <a:pPr>
-              <a:spcAft>
-                <a:spcPts val="1000"/>
-              </a:spcAft>
-              <a:defRPr sz="1800">
-                <a:solidFill>
-                  <a:srgbClr val="1E1E1E"/>
-                </a:solidFill>
-                <a:latin typeface="Times New Roman"/>
-              </a:defRPr>
-            </a:pPr>
-            <a:r>
-              <a:t>Real-time sentiment polarity tracking.</a:t>
-            </a:r>
-          </a:p>
-          <a:p>
-            <a:pPr>
-              <a:spcAft>
-                <a:spcPts val="1000"/>
-              </a:spcAft>
-              <a:defRPr sz="1800">
-                <a:solidFill>
-                  <a:srgbClr val="1E1E1E"/>
-                </a:solidFill>
-                <a:latin typeface="Times New Roman"/>
-              </a:defRPr>
-            </a:pPr>
-            <a:r>
-              <a:t>Sub-200ms query response latency.</a:t>
-            </a:r>
-          </a:p>
-          <a:p>
-            <a:pPr>
-              <a:spcAft>
-                <a:spcPts val="1000"/>
-              </a:spcAft>
-              <a:defRPr sz="1800">
-                <a:solidFill>
-                  <a:srgbClr val="1E1E1E"/>
-                </a:solidFill>
-                <a:latin typeface="Times New Roman"/>
-              </a:defRPr>
-            </a:pPr>
-            <a:r>
-              <a:t>High correlation in interest matching.</a:t>
-            </a:r>
-          </a:p>
-        </p:txBody>
-      </p:sp>
-      <p:sp>
-        <p:nvSpPr>
-          <p:cNvPr id="6" name="Rectangle 5"/>
-          <p:cNvSpPr/>
-          <p:nvPr/>
-        </p:nvSpPr>
-        <p:spPr>
-          <a:xfrm>
-            <a:off x="5486400" y="1828800"/>
-            <a:ext cx="1066799" cy="731520"/>
-          </a:xfrm>
-          <a:prstGeom prst="rect">
-            <a:avLst/>
-          </a:prstGeom>
-          <a:solidFill>
-            <a:srgbClr val="002147"/>
-          </a:solidFill>
-        </p:spPr>
-        <p:style>
-          <a:lnRef idx="1">
-            <a:schemeClr val="accent1"/>
-          </a:lnRef>
-          <a:fillRef idx="3">
-            <a:schemeClr val="accent1"/>
-          </a:fillRef>
-          <a:effectRef idx="2">
-            <a:schemeClr val="accent1"/>
-          </a:effectRef>
-          <a:fontRef idx="minor">
-            <a:schemeClr val="lt1"/>
-          </a:fontRef>
-        </p:style>
-        <p:txBody>
-          <a:bodyPr rtlCol="0" anchor="ctr"/>
-          <a:lstStyle/>
-          <a:p>
-            <a:pPr algn="ctr"/>
-          </a:p>
-        </p:txBody>
-      </p:sp>
-      <p:sp>
-        <p:nvSpPr>
-          <p:cNvPr id="7" name="TextBox 6"/>
-          <p:cNvSpPr txBox="1"/>
-          <p:nvPr/>
-        </p:nvSpPr>
-        <p:spPr>
-          <a:xfrm>
-            <a:off x="5486400" y="1554480"/>
-            <a:ext cx="3200400" cy="274320"/>
-          </a:xfrm>
-          <a:prstGeom prst="rect">
-            <a:avLst/>
-          </a:prstGeom>
-          <a:noFill/>
-        </p:spPr>
-        <p:txBody>
-          <a:bodyPr wrap="none">
-            <a:spAutoFit/>
-          </a:bodyPr>
-          <a:lstStyle/>
-          <a:p>
-            <a:pPr>
-              <a:defRPr sz="1400" b="1">
-                <a:latin typeface="Times New Roman"/>
-              </a:defRPr>
-            </a:pPr>
-            <a:r>
-              <a:t>Neutral (0.0)</a:t>
-            </a:r>
-          </a:p>
-        </p:txBody>
-      </p:sp>
-      <p:sp>
-        <p:nvSpPr>
-          <p:cNvPr id="8" name="Rectangle 7"/>
-          <p:cNvSpPr/>
-          <p:nvPr/>
-        </p:nvSpPr>
-        <p:spPr>
-          <a:xfrm>
-            <a:off x="5486400" y="2926080"/>
-            <a:ext cx="2667000" cy="731520"/>
-          </a:xfrm>
-          <a:prstGeom prst="rect">
-            <a:avLst/>
-          </a:prstGeom>
-          <a:solidFill>
-            <a:srgbClr val="002147"/>
-          </a:solidFill>
-        </p:spPr>
-        <p:style>
-          <a:lnRef idx="1">
-            <a:schemeClr val="accent1"/>
-          </a:lnRef>
-          <a:fillRef idx="3">
-            <a:schemeClr val="accent1"/>
-          </a:fillRef>
-          <a:effectRef idx="2">
-            <a:schemeClr val="accent1"/>
-          </a:effectRef>
-          <a:fontRef idx="minor">
-            <a:schemeClr val="lt1"/>
-          </a:fontRef>
-        </p:style>
-        <p:txBody>
-          <a:bodyPr rtlCol="0" anchor="ctr"/>
-          <a:lstStyle/>
-          <a:p>
-            <a:pPr algn="ctr"/>
-          </a:p>
-        </p:txBody>
-      </p:sp>
-      <p:sp>
-        <p:nvSpPr>
-          <p:cNvPr id="9" name="TextBox 8"/>
-          <p:cNvSpPr txBox="1"/>
-          <p:nvPr/>
-        </p:nvSpPr>
-        <p:spPr>
-          <a:xfrm>
-            <a:off x="5486400" y="2651760"/>
-            <a:ext cx="3200400" cy="274320"/>
-          </a:xfrm>
-          <a:prstGeom prst="rect">
-            <a:avLst/>
-          </a:prstGeom>
-          <a:noFill/>
-        </p:spPr>
-        <p:txBody>
-          <a:bodyPr wrap="none">
-            <a:spAutoFit/>
-          </a:bodyPr>
-          <a:lstStyle/>
-          <a:p>
-            <a:pPr>
-              <a:defRPr sz="1400" b="1">
-                <a:latin typeface="Times New Roman"/>
-              </a:defRPr>
-            </a:pPr>
-            <a:r>
-              <a:t>Positive (&gt;0)</a:t>
-            </a:r>
-          </a:p>
-        </p:txBody>
-      </p:sp>
-      <p:sp>
-        <p:nvSpPr>
-          <p:cNvPr id="10" name="Rectangle 9"/>
-          <p:cNvSpPr/>
-          <p:nvPr/>
-        </p:nvSpPr>
-        <p:spPr>
-          <a:xfrm>
-            <a:off x="5486400" y="4023360"/>
-            <a:ext cx="1386840" cy="731520"/>
-          </a:xfrm>
-          <a:prstGeom prst="rect">
-            <a:avLst/>
-          </a:prstGeom>
-          <a:solidFill>
-            <a:srgbClr val="C8102E"/>
-          </a:solidFill>
-        </p:spPr>
-        <p:style>
-          <a:lnRef idx="1">
-            <a:schemeClr val="accent1"/>
-          </a:lnRef>
-          <a:fillRef idx="3">
-            <a:schemeClr val="accent1"/>
-          </a:fillRef>
-          <a:effectRef idx="2">
-            <a:schemeClr val="accent1"/>
-          </a:effectRef>
-          <a:fontRef idx="minor">
-            <a:schemeClr val="lt1"/>
-          </a:fontRef>
-        </p:style>
-        <p:txBody>
-          <a:bodyPr rtlCol="0" anchor="ctr"/>
-          <a:lstStyle/>
-          <a:p>
-            <a:pPr algn="ctr"/>
-          </a:p>
-        </p:txBody>
-      </p:sp>
-      <p:sp>
-        <p:nvSpPr>
-          <p:cNvPr id="11" name="TextBox 10"/>
-          <p:cNvSpPr txBox="1"/>
-          <p:nvPr/>
-        </p:nvSpPr>
-        <p:spPr>
-          <a:xfrm>
-            <a:off x="5486400" y="3749039"/>
-            <a:ext cx="3200400" cy="274320"/>
-          </a:xfrm>
-          <a:prstGeom prst="rect">
-            <a:avLst/>
-          </a:prstGeom>
-          <a:noFill/>
-        </p:spPr>
-        <p:txBody>
-          <a:bodyPr wrap="none">
-            <a:spAutoFit/>
-          </a:bodyPr>
-          <a:lstStyle/>
-          <a:p>
-            <a:pPr>
-              <a:defRPr sz="1400" b="1">
-                <a:latin typeface="Times New Roman"/>
-              </a:defRPr>
-            </a:pPr>
-            <a:r>
-              <a:t>Negative (&lt;0)</a:t>
-            </a:r>
-          </a:p>
-        </p:txBody>
-      </p:sp>
-    </p:spTree>
-  </p:cSld>
-  <p:clrMapOvr>
-    <a:masterClrMapping/>
-  </p:clrMapOvr>
-</p:sld>
-</file>
-
-<file path=ppt/slides/slide7.xml><?xml version="1.0" encoding="utf-8"?>
-<p:sld xmlns:a="http://schemas.openxmlformats.org/drawingml/2006/main" xmlns:p="http://schemas.openxmlformats.org/presentationml/2006/main" xmlns:r="http://schemas.openxmlformats.org/officeDocument/2006/relationships">
-  <p:cSld>
-    <p:spTree>
-      <p:nvGrpSpPr>
-        <p:cNvPr id="1" name=""/>
-        <p:cNvGrpSpPr/>
-        <p:nvPr/>
-      </p:nvGrpSpPr>
-      <p:grpSpPr/>
-      <p:sp>
-        <p:nvSpPr>
-          <p:cNvPr id="2" name="Rectangle 1"/>
-          <p:cNvSpPr/>
-          <p:nvPr/>
-        </p:nvSpPr>
-        <p:spPr>
-          <a:xfrm>
-            <a:off x="0" y="0"/>
-            <a:ext cx="9144000" cy="777240"/>
-          </a:xfrm>
-          <a:prstGeom prst="rect">
-            <a:avLst/>
-          </a:prstGeom>
-          <a:solidFill>
-            <a:srgbClr val="002147"/>
-          </a:solidFill>
-          <a:ln>
-            <a:noFill/>
-          </a:ln>
-        </p:spPr>
-        <p:style>
-          <a:lnRef idx="1">
-            <a:schemeClr val="accent1"/>
-          </a:lnRef>
-          <a:fillRef idx="3">
-            <a:schemeClr val="accent1"/>
-          </a:fillRef>
-          <a:effectRef idx="2">
-            <a:schemeClr val="accent1"/>
-          </a:effectRef>
-          <a:fontRef idx="minor">
-            <a:schemeClr val="lt1"/>
-          </a:fontRef>
-        </p:style>
-        <p:txBody>
-          <a:bodyPr rtlCol="0" anchor="ctr"/>
-          <a:lstStyle/>
-          <a:p>
-            <a:pPr algn="ctr"/>
-          </a:p>
-        </p:txBody>
-      </p:sp>
-      <p:sp>
-        <p:nvSpPr>
-          <p:cNvPr id="3" name="TextBox 2"/>
-          <p:cNvSpPr txBox="1"/>
-          <p:nvPr/>
-        </p:nvSpPr>
-        <p:spPr>
-          <a:xfrm>
-            <a:off x="365760" y="91440"/>
-            <a:ext cx="8412480" cy="640080"/>
-          </a:xfrm>
-          <a:prstGeom prst="rect">
-            <a:avLst/>
-          </a:prstGeom>
-          <a:noFill/>
-        </p:spPr>
-        <p:txBody>
-          <a:bodyPr wrap="none">
-            <a:spAutoFit/>
-          </a:bodyPr>
-          <a:lstStyle/>
-          <a:p>
-            <a:r>
-              <a:rPr sz="2800" b="1">
-                <a:solidFill>
-                  <a:srgbClr val="FFFFFF"/>
-                </a:solidFill>
-                <a:latin typeface="Times New Roman"/>
-              </a:rPr>
-              <a:t>Findings &amp; Results</a:t>
-            </a:r>
-          </a:p>
-        </p:txBody>
-      </p:sp>
-      <p:sp>
-        <p:nvSpPr>
-          <p:cNvPr id="4" name="TextBox 3"/>
-          <p:cNvSpPr txBox="1"/>
-          <p:nvPr/>
-        </p:nvSpPr>
-        <p:spPr>
-          <a:xfrm>
-            <a:off x="457200" y="1097280"/>
-            <a:ext cx="4754880" cy="4572000"/>
-          </a:xfrm>
-          <a:prstGeom prst="rect">
-            <a:avLst/>
-          </a:prstGeom>
-          <a:noFill/>
-        </p:spPr>
-        <p:txBody>
-          <a:bodyPr wrap="square">
-            <a:spAutoFit/>
-          </a:bodyPr>
-          <a:lstStyle/>
-          <a:p>
-            <a:pPr>
-              <a:spcAft>
-                <a:spcPts val="1000"/>
-              </a:spcAft>
-              <a:defRPr sz="1800">
-                <a:solidFill>
-                  <a:srgbClr val="1E1E1E"/>
-                </a:solidFill>
-                <a:latin typeface="Times New Roman"/>
-              </a:defRPr>
-            </a:pPr>
-            <a:r>
-              <a:t>95% functional accuracy in Cloud DB tests.</a:t>
-            </a:r>
-          </a:p>
-          <a:p>
-            <a:pPr>
-              <a:spcAft>
-                <a:spcPts val="1000"/>
-              </a:spcAft>
-              <a:defRPr sz="1800">
-                <a:solidFill>
-                  <a:srgbClr val="1E1E1E"/>
-                </a:solidFill>
-                <a:latin typeface="Times New Roman"/>
-              </a:defRPr>
-            </a:pPr>
-            <a:r>
-              <a:t>150+ programs accurately mapped.</a:t>
-            </a:r>
-          </a:p>
-          <a:p>
-            <a:pPr>
-              <a:spcAft>
-                <a:spcPts val="1000"/>
-              </a:spcAft>
-              <a:defRPr sz="1800">
-                <a:solidFill>
-                  <a:srgbClr val="1E1E1E"/>
-                </a:solidFill>
-                <a:latin typeface="Times New Roman"/>
-              </a:defRPr>
-            </a:pPr>
-            <a:r>
-              <a:t>Eliminated database fragmentation issues.</a:t>
-            </a:r>
-          </a:p>
-          <a:p>
-            <a:pPr>
-              <a:spcAft>
-                <a:spcPts val="1000"/>
-              </a:spcAft>
-              <a:defRPr sz="1800">
-                <a:solidFill>
-                  <a:srgbClr val="1E1E1E"/>
-                </a:solidFill>
-                <a:latin typeface="Times New Roman"/>
-              </a:defRPr>
-            </a:pPr>
-            <a:r>
-              <a:t>Verified Mon-Fri booking validation.</a:t>
-            </a:r>
-          </a:p>
-          <a:p>
-            <a:pPr>
-              <a:spcAft>
-                <a:spcPts val="1000"/>
-              </a:spcAft>
-              <a:defRPr sz="1800">
-                <a:solidFill>
-                  <a:srgbClr val="1E1E1E"/>
-                </a:solidFill>
-                <a:latin typeface="Times New Roman"/>
-              </a:defRPr>
-            </a:pPr>
-            <a:r>
-              <a:t>Unified logs for centralized monitoring.</a:t>
-            </a:r>
-          </a:p>
-        </p:txBody>
-      </p:sp>
-      <p:sp>
-        <p:nvSpPr>
-          <p:cNvPr id="5" name="TextBox 4"/>
-          <p:cNvSpPr txBox="1"/>
-          <p:nvPr/>
-        </p:nvSpPr>
-        <p:spPr>
-          <a:xfrm>
-            <a:off x="0" y="6492240"/>
-            <a:ext cx="9144000" cy="274320"/>
-          </a:xfrm>
-          <a:prstGeom prst="rect">
-            <a:avLst/>
-          </a:prstGeom>
-          <a:noFill/>
-        </p:spPr>
-        <p:txBody>
-          <a:bodyPr wrap="none">
-            <a:spAutoFit/>
-          </a:bodyPr>
-          <a:lstStyle/>
-          <a:p>
-            <a:pPr algn="ctr">
-              <a:defRPr sz="1000">
-                <a:solidFill>
-                  <a:srgbClr val="808080"/>
-                </a:solidFill>
-                <a:latin typeface="Times New Roman"/>
-              </a:defRPr>
-            </a:pPr>
-            <a:r>
-              <a:t>Manik | O24MCA110817 | MCA Final Project Defense | Slide 7</a:t>
-            </a:r>
-          </a:p>
-        </p:txBody>
-      </p:sp>
-    </p:spTree>
-  </p:cSld>
-  <p:clrMapOvr>
-    <a:masterClrMapping/>
-  </p:clrMapOvr>
-</p:sld>
-</file>
-
-<file path=ppt/slides/slide8.xml><?xml version="1.0" encoding="utf-8"?>
-<p:sld xmlns:a="http://schemas.openxmlformats.org/drawingml/2006/main" xmlns:p="http://schemas.openxmlformats.org/presentationml/2006/main" xmlns:r="http://schemas.openxmlformats.org/officeDocument/2006/relationships">
-  <p:cSld>
-    <p:spTree>
-      <p:nvGrpSpPr>
-        <p:cNvPr id="1" name=""/>
-        <p:cNvGrpSpPr/>
-        <p:nvPr/>
-      </p:nvGrpSpPr>
-      <p:grpSpPr/>
-      <p:sp>
-        <p:nvSpPr>
-          <p:cNvPr id="2" name="Rectangle 1"/>
-          <p:cNvSpPr/>
-          <p:nvPr/>
-        </p:nvSpPr>
-        <p:spPr>
-          <a:xfrm>
-            <a:off x="0" y="0"/>
-            <a:ext cx="9144000" cy="777240"/>
-          </a:xfrm>
-          <a:prstGeom prst="rect">
-            <a:avLst/>
-          </a:prstGeom>
-          <a:solidFill>
-            <a:srgbClr val="002147"/>
-          </a:solidFill>
-          <a:ln>
-            <a:noFill/>
-          </a:ln>
-        </p:spPr>
-        <p:style>
-          <a:lnRef idx="1">
-            <a:schemeClr val="accent1"/>
-          </a:lnRef>
-          <a:fillRef idx="3">
-            <a:schemeClr val="accent1"/>
-          </a:fillRef>
-          <a:effectRef idx="2">
-            <a:schemeClr val="accent1"/>
-          </a:effectRef>
-          <a:fontRef idx="minor">
-            <a:schemeClr val="lt1"/>
-          </a:fontRef>
-        </p:style>
-        <p:txBody>
-          <a:bodyPr rtlCol="0" anchor="ctr"/>
-          <a:lstStyle/>
-          <a:p>
-            <a:pPr algn="ctr"/>
-          </a:p>
-        </p:txBody>
-      </p:sp>
-      <p:sp>
-        <p:nvSpPr>
-          <p:cNvPr id="3" name="TextBox 2"/>
-          <p:cNvSpPr txBox="1"/>
-          <p:nvPr/>
-        </p:nvSpPr>
-        <p:spPr>
-          <a:xfrm>
-            <a:off x="365760" y="91440"/>
-            <a:ext cx="8412480" cy="640080"/>
-          </a:xfrm>
-          <a:prstGeom prst="rect">
-            <a:avLst/>
-          </a:prstGeom>
-          <a:noFill/>
-        </p:spPr>
-        <p:txBody>
-          <a:bodyPr wrap="none">
-            <a:spAutoFit/>
-          </a:bodyPr>
-          <a:lstStyle/>
-          <a:p>
-            <a:r>
-              <a:rPr sz="2800" b="1">
-                <a:solidFill>
-                  <a:srgbClr val="FFFFFF"/>
-                </a:solidFill>
-                <a:latin typeface="Times New Roman"/>
-              </a:rPr>
-              <a:t>Conclusions</a:t>
-            </a:r>
-          </a:p>
-        </p:txBody>
-      </p:sp>
-      <p:sp>
-        <p:nvSpPr>
-          <p:cNvPr id="4" name="TextBox 3"/>
-          <p:cNvSpPr txBox="1"/>
-          <p:nvPr/>
-        </p:nvSpPr>
-        <p:spPr>
-          <a:xfrm>
-            <a:off x="457200" y="1097280"/>
-            <a:ext cx="4754880" cy="4572000"/>
-          </a:xfrm>
-          <a:prstGeom prst="rect">
-            <a:avLst/>
-          </a:prstGeom>
-          <a:noFill/>
-        </p:spPr>
-        <p:txBody>
-          <a:bodyPr wrap="square">
-            <a:spAutoFit/>
-          </a:bodyPr>
-          <a:lstStyle/>
-          <a:p>
-            <a:pPr>
-              <a:spcAft>
-                <a:spcPts val="1000"/>
-              </a:spcAft>
-              <a:defRPr sz="1800">
-                <a:solidFill>
-                  <a:srgbClr val="1E1E1E"/>
-                </a:solidFill>
-                <a:latin typeface="Times New Roman"/>
-              </a:defRPr>
-            </a:pPr>
-            <a:r>
-              <a:t>Unified Cloud DB is the sustainable path.</a:t>
-            </a:r>
-          </a:p>
-          <a:p>
-            <a:pPr>
-              <a:spcAft>
-                <a:spcPts val="1000"/>
-              </a:spcAft>
-              <a:defRPr sz="1800">
-                <a:solidFill>
-                  <a:srgbClr val="1E1E1E"/>
-                </a:solidFill>
-                <a:latin typeface="Times New Roman"/>
-              </a:defRPr>
-            </a:pPr>
-            <a:r>
-              <a:t>Absolute data sovereignty achieved.</a:t>
-            </a:r>
-          </a:p>
-          <a:p>
-            <a:pPr>
-              <a:spcAft>
-                <a:spcPts val="1000"/>
-              </a:spcAft>
-              <a:defRPr sz="1800">
-                <a:solidFill>
-                  <a:srgbClr val="1E1E1E"/>
-                </a:solidFill>
-                <a:latin typeface="Times New Roman"/>
-              </a:defRPr>
-            </a:pPr>
-            <a:r>
-              <a:t>Production-ready ecosystem delivered.</a:t>
-            </a:r>
-          </a:p>
-          <a:p>
-            <a:pPr>
-              <a:spcAft>
-                <a:spcPts val="1000"/>
-              </a:spcAft>
-              <a:defRPr sz="1800">
-                <a:solidFill>
-                  <a:srgbClr val="1E1E1E"/>
-                </a:solidFill>
-                <a:latin typeface="Times New Roman"/>
-              </a:defRPr>
-            </a:pPr>
-            <a:r>
-              <a:t>Optimized for institutional deployment.</a:t>
-            </a:r>
-          </a:p>
-        </p:txBody>
-      </p:sp>
-      <p:sp>
-        <p:nvSpPr>
-          <p:cNvPr id="5" name="TextBox 4"/>
-          <p:cNvSpPr txBox="1"/>
-          <p:nvPr/>
-        </p:nvSpPr>
-        <p:spPr>
-          <a:xfrm>
-            <a:off x="0" y="6492240"/>
-            <a:ext cx="9144000" cy="274320"/>
-          </a:xfrm>
-          <a:prstGeom prst="rect">
-            <a:avLst/>
-          </a:prstGeom>
-          <a:noFill/>
-        </p:spPr>
-        <p:txBody>
-          <a:bodyPr wrap="none">
-            <a:spAutoFit/>
-          </a:bodyPr>
-          <a:lstStyle/>
-          <a:p>
-            <a:pPr algn="ctr">
-              <a:defRPr sz="1000">
-                <a:solidFill>
-                  <a:srgbClr val="808080"/>
-                </a:solidFill>
-                <a:latin typeface="Times New Roman"/>
-              </a:defRPr>
-            </a:pPr>
-            <a:r>
-              <a:t>Manik | O24MCA110817 | MCA Final Project Defense | Slide 8</a:t>
-            </a:r>
-          </a:p>
-        </p:txBody>
-      </p:sp>
-    </p:spTree>
-  </p:cSld>
-  <p:clrMapOvr>
-    <a:masterClrMapping/>
-  </p:clrMapOvr>
-</p:sld>
-</file>
-
-<file path=ppt/slides/slide9.xml><?xml version="1.0" encoding="utf-8"?>
-<p:sld xmlns:a="http://schemas.openxmlformats.org/drawingml/2006/main" xmlns:p="http://schemas.openxmlformats.org/presentationml/2006/main" xmlns:r="http://schemas.openxmlformats.org/officeDocument/2006/relationships">
-  <p:cSld>
-    <p:spTree>
-      <p:nvGrpSpPr>
-        <p:cNvPr id="1" name=""/>
-        <p:cNvGrpSpPr/>
-        <p:nvPr/>
-      </p:nvGrpSpPr>
-      <p:grpSpPr/>
-      <p:sp>
-        <p:nvSpPr>
-          <p:cNvPr id="2" name="Rectangle 1"/>
-          <p:cNvSpPr/>
-          <p:nvPr/>
-        </p:nvSpPr>
-        <p:spPr>
-          <a:xfrm>
-            <a:off x="0" y="0"/>
-            <a:ext cx="9144000" cy="777240"/>
-          </a:xfrm>
-          <a:prstGeom prst="rect">
-            <a:avLst/>
-          </a:prstGeom>
-          <a:solidFill>
-            <a:srgbClr val="002147"/>
-          </a:solidFill>
-          <a:ln>
-            <a:noFill/>
-          </a:ln>
-        </p:spPr>
-        <p:style>
-          <a:lnRef idx="1">
-            <a:schemeClr val="accent1"/>
-          </a:lnRef>
-          <a:fillRef idx="3">
-            <a:schemeClr val="accent1"/>
-          </a:fillRef>
-          <a:effectRef idx="2">
-            <a:schemeClr val="accent1"/>
-          </a:effectRef>
-          <a:fontRef idx="minor">
-            <a:schemeClr val="lt1"/>
-          </a:fontRef>
-        </p:style>
-        <p:txBody>
-          <a:bodyPr rtlCol="0" anchor="ctr"/>
-          <a:lstStyle/>
-          <a:p>
-            <a:pPr algn="ctr"/>
-          </a:p>
-        </p:txBody>
-      </p:sp>
-      <p:sp>
-        <p:nvSpPr>
-          <p:cNvPr id="3" name="TextBox 2"/>
-          <p:cNvSpPr txBox="1"/>
-          <p:nvPr/>
-        </p:nvSpPr>
-        <p:spPr>
-          <a:xfrm>
-            <a:off x="365760" y="91440"/>
-            <a:ext cx="8412480" cy="640080"/>
-          </a:xfrm>
-          <a:prstGeom prst="rect">
-            <a:avLst/>
-          </a:prstGeom>
-          <a:noFill/>
-        </p:spPr>
-        <p:txBody>
-          <a:bodyPr wrap="none">
-            <a:spAutoFit/>
-          </a:bodyPr>
-          <a:lstStyle/>
-          <a:p>
-            <a:r>
-              <a:rPr sz="2800" b="1">
-                <a:solidFill>
-                  <a:srgbClr val="FFFFFF"/>
-                </a:solidFill>
-                <a:latin typeface="Times New Roman"/>
-              </a:rPr>
-              <a:t>Recommendations</a:t>
-            </a:r>
-          </a:p>
-        </p:txBody>
-      </p:sp>
-      <p:sp>
-        <p:nvSpPr>
-          <p:cNvPr id="4" name="TextBox 3"/>
-          <p:cNvSpPr txBox="1"/>
-          <p:nvPr/>
-        </p:nvSpPr>
-        <p:spPr>
-          <a:xfrm>
-            <a:off x="457200" y="1097280"/>
-            <a:ext cx="4754880" cy="4572000"/>
-          </a:xfrm>
-          <a:prstGeom prst="rect">
-            <a:avLst/>
-          </a:prstGeom>
-          <a:noFill/>
-        </p:spPr>
-        <p:txBody>
-          <a:bodyPr wrap="square">
-            <a:spAutoFit/>
-          </a:bodyPr>
-          <a:lstStyle/>
-          <a:p>
-            <a:pPr>
-              <a:spcAft>
-                <a:spcPts val="1000"/>
-              </a:spcAft>
-              <a:defRPr sz="1800">
-                <a:solidFill>
-                  <a:srgbClr val="1E1E1E"/>
-                </a:solidFill>
-                <a:latin typeface="Times New Roman"/>
-              </a:defRPr>
-            </a:pPr>
-            <a:r>
-              <a:t>Direct CU-IMS API integration.</a:t>
-            </a:r>
-          </a:p>
-          <a:p>
-            <a:pPr>
-              <a:spcAft>
-                <a:spcPts val="1000"/>
-              </a:spcAft>
-              <a:defRPr sz="1800">
-                <a:solidFill>
-                  <a:srgbClr val="1E1E1E"/>
-                </a:solidFill>
-                <a:latin typeface="Times New Roman"/>
-              </a:defRPr>
-            </a:pPr>
-            <a:r>
-              <a:t>Hindi/Punjabi multi-lingual support.</a:t>
-            </a:r>
-          </a:p>
-          <a:p>
-            <a:pPr>
-              <a:spcAft>
-                <a:spcPts val="1000"/>
-              </a:spcAft>
-              <a:defRPr sz="1800">
-                <a:solidFill>
-                  <a:srgbClr val="1E1E1E"/>
-                </a:solidFill>
-                <a:latin typeface="Times New Roman"/>
-              </a:defRPr>
-            </a:pPr>
-            <a:r>
-              <a:t>Predictive dropout risk analytics.</a:t>
-            </a:r>
-          </a:p>
-          <a:p>
-            <a:pPr>
-              <a:spcAft>
-                <a:spcPts val="1000"/>
-              </a:spcAft>
-              <a:defRPr sz="1800">
-                <a:solidFill>
-                  <a:srgbClr val="1E1E1E"/>
-                </a:solidFill>
-                <a:latin typeface="Times New Roman"/>
-              </a:defRPr>
-            </a:pPr>
-            <a:r>
-              <a:t>Native PWA for mobile notifications.</a:t>
-            </a:r>
-          </a:p>
-        </p:txBody>
-      </p:sp>
-      <p:sp>
-        <p:nvSpPr>
-          <p:cNvPr id="5" name="TextBox 4"/>
-          <p:cNvSpPr txBox="1"/>
-          <p:nvPr/>
-        </p:nvSpPr>
-        <p:spPr>
-          <a:xfrm>
-            <a:off x="0" y="6492240"/>
-            <a:ext cx="9144000" cy="274320"/>
-          </a:xfrm>
-          <a:prstGeom prst="rect">
-            <a:avLst/>
-          </a:prstGeom>
-          <a:noFill/>
-        </p:spPr>
-        <p:txBody>
-          <a:bodyPr wrap="none">
-            <a:spAutoFit/>
-          </a:bodyPr>
-          <a:lstStyle/>
-          <a:p>
-            <a:pPr algn="ctr">
-              <a:defRPr sz="1000">
-                <a:solidFill>
-                  <a:srgbClr val="808080"/>
-                </a:solidFill>
-                <a:latin typeface="Times New Roman"/>
-              </a:defRPr>
-            </a:pPr>
-            <a:r>
-              <a:t>Manik | O24MCA110817 | MCA Final Project Defense | Slide 9</a:t>
+              <a:t>Manik | CU AI Advisor | Aiven Production Deployment | Slide 5</a:t>
             </a:r>
           </a:p>
         </p:txBody>

</xml_diff>